<commit_message>
Refine presentation speaker notes
</commit_message>
<xml_diff>
--- a/capstone/work/milestone7/Milestone7_Presentation_Final.pptx
+++ b/capstone/work/milestone7/Milestone7_Presentation_Final.pptx
@@ -2,32 +2,32 @@
 <file path=ppt/presentation.xml><?xml version="1.0" encoding="utf-8"?>
 <p:presentation xmlns:p="http://schemas.openxmlformats.org/presentationml/2006/main">
   <p:sldMasterIdLst>
-    <p:sldMasterId xmlns:r="http://schemas.openxmlformats.org/officeDocument/2006/relationships" id="2147483648" r:id="Rd6b42826452a4c91"/>
+    <p:sldMasterId xmlns:r="http://schemas.openxmlformats.org/officeDocument/2006/relationships" id="2147483648" r:id="Rf2fde79c6beb4985"/>
   </p:sldMasterIdLst>
   <p:notesMasterIdLst>
-    <p:notesMasterId xmlns:r="http://schemas.openxmlformats.org/officeDocument/2006/relationships" r:id="Rc929d79a252b4882"/>
+    <p:notesMasterId xmlns:r="http://schemas.openxmlformats.org/officeDocument/2006/relationships" r:id="R92ad3d81c0d84aa9"/>
   </p:notesMasterIdLst>
   <p:sldIdLst>
-    <p:sldId xmlns:r="http://schemas.openxmlformats.org/officeDocument/2006/relationships" id="256" r:id="Rfd7c2fbb0b9f4589"/>
-    <p:sldId xmlns:r="http://schemas.openxmlformats.org/officeDocument/2006/relationships" id="257" r:id="R2c5e75d1a56b48f2"/>
-    <p:sldId xmlns:r="http://schemas.openxmlformats.org/officeDocument/2006/relationships" id="258" r:id="R76407992d7194eb5"/>
-    <p:sldId xmlns:r="http://schemas.openxmlformats.org/officeDocument/2006/relationships" id="259" r:id="R801ce0de690c4980"/>
-    <p:sldId xmlns:r="http://schemas.openxmlformats.org/officeDocument/2006/relationships" id="260" r:id="R58fc615491a14a9b"/>
-    <p:sldId xmlns:r="http://schemas.openxmlformats.org/officeDocument/2006/relationships" id="261" r:id="Rf84030a9285941b1"/>
-    <p:sldId xmlns:r="http://schemas.openxmlformats.org/officeDocument/2006/relationships" id="262" r:id="Re7fa4f8a79b54885"/>
-    <p:sldId xmlns:r="http://schemas.openxmlformats.org/officeDocument/2006/relationships" id="263" r:id="R6c6d8741db5442a7"/>
-    <p:sldId xmlns:r="http://schemas.openxmlformats.org/officeDocument/2006/relationships" id="264" r:id="R40c1c5efd9bc40af"/>
-    <p:sldId xmlns:r="http://schemas.openxmlformats.org/officeDocument/2006/relationships" id="265" r:id="R699d3591dc87452c"/>
-    <p:sldId xmlns:r="http://schemas.openxmlformats.org/officeDocument/2006/relationships" id="266" r:id="Re9ed3692218b4792"/>
-    <p:sldId xmlns:r="http://schemas.openxmlformats.org/officeDocument/2006/relationships" id="267" r:id="R63ce83e2856147fb"/>
-    <p:sldId xmlns:r="http://schemas.openxmlformats.org/officeDocument/2006/relationships" id="268" r:id="Reb52d9d8f39d40df"/>
-    <p:sldId xmlns:r="http://schemas.openxmlformats.org/officeDocument/2006/relationships" id="269" r:id="R288c0bb5e50c474e"/>
-    <p:sldId xmlns:r="http://schemas.openxmlformats.org/officeDocument/2006/relationships" id="270" r:id="R92dd8dafc70c4245"/>
-    <p:sldId xmlns:r="http://schemas.openxmlformats.org/officeDocument/2006/relationships" id="271" r:id="R4eedf2b098c74d37"/>
-    <p:sldId xmlns:r="http://schemas.openxmlformats.org/officeDocument/2006/relationships" id="272" r:id="R85427f7e6eea430c"/>
-    <p:sldId xmlns:r="http://schemas.openxmlformats.org/officeDocument/2006/relationships" id="273" r:id="Rfa474b0ecf8b45b1"/>
-    <p:sldId xmlns:r="http://schemas.openxmlformats.org/officeDocument/2006/relationships" id="274" r:id="R4e73388a18eb48ee"/>
-    <p:sldId xmlns:r="http://schemas.openxmlformats.org/officeDocument/2006/relationships" id="275" r:id="R1ad8d77a63634580"/>
+    <p:sldId xmlns:r="http://schemas.openxmlformats.org/officeDocument/2006/relationships" id="256" r:id="Re0c8c377d24b4561"/>
+    <p:sldId xmlns:r="http://schemas.openxmlformats.org/officeDocument/2006/relationships" id="257" r:id="R2c0b352f870446c2"/>
+    <p:sldId xmlns:r="http://schemas.openxmlformats.org/officeDocument/2006/relationships" id="258" r:id="Rdc9a60c82c604087"/>
+    <p:sldId xmlns:r="http://schemas.openxmlformats.org/officeDocument/2006/relationships" id="259" r:id="R2a33f03924834b35"/>
+    <p:sldId xmlns:r="http://schemas.openxmlformats.org/officeDocument/2006/relationships" id="260" r:id="R2206f97d7f774a09"/>
+    <p:sldId xmlns:r="http://schemas.openxmlformats.org/officeDocument/2006/relationships" id="261" r:id="R6a850b77c1974836"/>
+    <p:sldId xmlns:r="http://schemas.openxmlformats.org/officeDocument/2006/relationships" id="262" r:id="R65bf528436ca4f49"/>
+    <p:sldId xmlns:r="http://schemas.openxmlformats.org/officeDocument/2006/relationships" id="263" r:id="Rb4d8f84708b24981"/>
+    <p:sldId xmlns:r="http://schemas.openxmlformats.org/officeDocument/2006/relationships" id="264" r:id="R9bd4a14e6c0f4651"/>
+    <p:sldId xmlns:r="http://schemas.openxmlformats.org/officeDocument/2006/relationships" id="265" r:id="R8607e926b72443ed"/>
+    <p:sldId xmlns:r="http://schemas.openxmlformats.org/officeDocument/2006/relationships" id="266" r:id="Re10854c6c4d64017"/>
+    <p:sldId xmlns:r="http://schemas.openxmlformats.org/officeDocument/2006/relationships" id="267" r:id="R90edf1885dae4434"/>
+    <p:sldId xmlns:r="http://schemas.openxmlformats.org/officeDocument/2006/relationships" id="268" r:id="R0bfbb0ec42f34844"/>
+    <p:sldId xmlns:r="http://schemas.openxmlformats.org/officeDocument/2006/relationships" id="269" r:id="R762801c7d09840f7"/>
+    <p:sldId xmlns:r="http://schemas.openxmlformats.org/officeDocument/2006/relationships" id="270" r:id="Raeb9607cc1374331"/>
+    <p:sldId xmlns:r="http://schemas.openxmlformats.org/officeDocument/2006/relationships" id="271" r:id="Rc9c0f89577984807"/>
+    <p:sldId xmlns:r="http://schemas.openxmlformats.org/officeDocument/2006/relationships" id="272" r:id="R1401a4e17e5f4909"/>
+    <p:sldId xmlns:r="http://schemas.openxmlformats.org/officeDocument/2006/relationships" id="273" r:id="R34bfdebafffa490b"/>
+    <p:sldId xmlns:r="http://schemas.openxmlformats.org/officeDocument/2006/relationships" id="274" r:id="Rb4d0f8da15aa40dc"/>
+    <p:sldId xmlns:r="http://schemas.openxmlformats.org/officeDocument/2006/relationships" id="275" r:id="R2e58404ea14941c0"/>
   </p:sldIdLst>
   <p:sldSz cx="18288000" cy="10287000"/>
   <p:notesSz cx="6858000" cy="9144000"/>
@@ -596,10 +596,27 @@
           <a:lstStyle xmlns:a="http://schemas.openxmlformats.org/drawingml/2006/main"/>
           <a:p xmlns:a="http://schemas.openxmlformats.org/drawingml/2006/main">
             <a:r>
-              <a:t>Good afternoon. We are Group 21 — Xinyu Wang and Wu Hanming — presenting our capstone on an AI-based student dropout early warning system.
-Our project reproduces a published modelling approach on the UCI Portuguese dataset and then evaluates the same leakage-aware workflow separately on the OULAD dataset. We did not train on one dataset and test on the other, so this is a comparative evaluation, not a direct transfer.
-Two headline numbers sit on the right: ROC-AUC of 0.911 for the UCI Logistic Regression and 0.885 for the OULAD XGBoost. Per one thousand students, the models identify roughly 263 and 224 true at-risk students respectively.
-Our recommendation, at the bottom, is deliberately cautious: use these models to support a small human-in-the-loop advisor pilot. The break-even figure is a planning assumption, not an observed institutional outcome. We will walk through how we got here over the next 20 minutes.</a:t>
+              <a:t>Good afternoon. We are Group 21, Xinyu Wang and Wu Hanming. Our capstone is an AI-based student dropout early warning system.</a:t>
+            </a:r>
+          </a:p>
+          <a:p xmlns:a="http://schemas.openxmlformats.org/drawingml/2006/main">
+            <a:r>
+              <a:t/>
+            </a:r>
+          </a:p>
+          <a:p xmlns:a="http://schemas.openxmlformats.org/drawingml/2006/main">
+            <a:r>
+              <a:t>We first reproduced a published modelling approach on the UCI student dataset. We then applied the same leakage-aware workflow separately to OULAD, which contains online learning behaviour. This is a comparison across two educational settings, not a direct model transfer.</a:t>
+            </a:r>
+          </a:p>
+          <a:p xmlns:a="http://schemas.openxmlformats.org/drawingml/2006/main">
+            <a:r>
+              <a:t/>
+            </a:r>
+          </a:p>
+          <a:p xmlns:a="http://schemas.openxmlformats.org/drawingml/2006/main">
+            <a:r>
+              <a:t>Our selected models achieved ROC AUC scores of 0.911 on UCI and 0.885 on OULAD. Based on these results, we recommend a small human-in-the-loop advisor pilot rather than automated decisions.</a:t>
             </a:r>
           </a:p>
         </p:txBody>
@@ -669,7 +686,27 @@
           <a:lstStyle xmlns:a="http://schemas.openxmlformats.org/drawingml/2006/main"/>
           <a:p xmlns:a="http://schemas.openxmlformats.org/drawingml/2006/main">
             <a:r>
-              <a:t>The headline numbers on the held-out test set — kept fully untouched during tuning. UCI Logistic Regression: ROC-AUC 0.911, F1 0.793, recall 0.820, precision 0.766. OULAD XGBoost: ROC-AUC 0.885, F1 0.738, recall 0.719, precision 0.758. Terminology note: we use ‘validation set’ only for model and threshold selection, and ‘held-out test set’ for the final reported numbers on this slide. Both models retain useful discrimination on genuinely unseen data, but the framing stays cautious. UCI is a small dataset, OULAD has about 88 false negatives per 1,000 test observations, and neither model has been shown to be operationally stable across academic cycles. Errors and operational constraints still need human review — which is what our recommended pilot design is set up to provide.</a:t>
+              <a:t>These are the final held-out test results. UCI Logistic Regression achieved ROC AUC of 0.911 and F1 of 0.793. Its recall was 0.820 and precision was 0.766.</a:t>
+            </a:r>
+          </a:p>
+          <a:p xmlns:a="http://schemas.openxmlformats.org/drawingml/2006/main">
+            <a:r>
+              <a:t/>
+            </a:r>
+          </a:p>
+          <a:p xmlns:a="http://schemas.openxmlformats.org/drawingml/2006/main">
+            <a:r>
+              <a:t>OULAD XGBoost achieved ROC AUC of 0.885 and F1 of 0.738. Its recall was 0.719 and precision was 0.758.</a:t>
+            </a:r>
+          </a:p>
+          <a:p xmlns:a="http://schemas.openxmlformats.org/drawingml/2006/main">
+            <a:r>
+              <a:t/>
+            </a:r>
+          </a:p>
+          <a:p xmlns:a="http://schemas.openxmlformats.org/drawingml/2006/main">
+            <a:r>
+              <a:t>Both models show useful discrimination on unseen data. Still, UCI is relatively small, and OULAD misses about 88 at-risk cases per 1,000 test observations. These results support further pilot evaluation, not autonomous use.</a:t>
             </a:r>
           </a:p>
         </p:txBody>
@@ -739,7 +776,7 @@
           <a:lstStyle xmlns:a="http://schemas.openxmlformats.org/drawingml/2006/main"/>
           <a:p xmlns:a="http://schemas.openxmlformats.org/drawingml/2006/main">
             <a:r>
-              <a:t>This extension tests whether the amount of information available at different points in the course changes model performance. We use the same 32,593 OULAD records, the same held-out student membership, the same tuned XGBoost settings, and the same fixed probability threshold of 0.60. Only the available assessment and virtual learning environment history changes across day 35, day 60, and day 75.</a:t>
+              <a:t>We added this timing experiment to test whether more course history improves prediction. We kept the same 32,593 OULAD records, the same held-out students, the same tuned XGBoost settings, and the same fixed threshold of 0.60. Only the available history changes.</a:t>
             </a:r>
           </a:p>
           <a:p xmlns:a="http://schemas.openxmlformats.org/drawingml/2006/main">
@@ -749,7 +786,7 @@
           </a:p>
           <a:p xmlns:a="http://schemas.openxmlformats.org/drawingml/2006/main">
             <a:r>
-              <a:t>Held-out F1 rises from 0.682 at day 35 to 0.716 at day 60 and 0.738 at day 75. The paired bootstrap estimate for the day 75 minus day 35 F1 difference is about 0.056, with a 95 percent interval from 0.044 to 0.068. Because the interval stays above zero, the improvement is unlikely to be explained only by the particular test sample.</a:t>
+              <a:t>Held-out F1 increases from 0.682 at day 35, to 0.716 at day 60, and 0.738 at day 75.</a:t>
             </a:r>
           </a:p>
           <a:p xmlns:a="http://schemas.openxmlformats.org/drawingml/2006/main">
@@ -759,7 +796,17 @@
           </a:p>
           <a:p xmlns:a="http://schemas.openxmlformats.org/drawingml/2006/main">
             <a:r>
-              <a:t>The practical point is a trade-off. Waiting until day 75 improves accuracy but leaves less time for advisors to act. Day 35 gives earlier warning but produces more mistakes. A real pilot would choose the observation window based on both model quality and the time needed to deliver support.</a:t>
+              <a:t>For day 75 minus day 35, the paired bootstrap F1 difference is about 0.056. The 95 percent confidence interval runs from 0.044 to 0.068 and does not include zero.</a:t>
+            </a:r>
+          </a:p>
+          <a:p xmlns:a="http://schemas.openxmlformats.org/drawingml/2006/main">
+            <a:r>
+              <a:t/>
+            </a:r>
+          </a:p>
+          <a:p xmlns:a="http://schemas.openxmlformats.org/drawingml/2006/main">
+            <a:r>
+              <a:t>The practical result is a trade-off: later prediction is more accurate, but earlier prediction leaves advisors more time to help.</a:t>
             </a:r>
           </a:p>
         </p:txBody>
@@ -829,10 +876,27 @@
           <a:lstStyle xmlns:a="http://schemas.openxmlformats.org/drawingml/2006/main"/>
           <a:p xmlns:a="http://schemas.openxmlformats.org/drawingml/2006/main">
             <a:r>
-              <a:t>This is the corrected SHAP feature-family chart. Every family present in either model is now shown — nothing is quietly missing.
-The pattern is very different between datasets. On UCI, Early academic progress accounts for about 44 percent of the total SHAP magnitude, followed by Financial support at 20 percent. On OULAD, Early academic progress is even more dominant at about 55 percent, but Early engagement — which is essentially zero on UCI — accounts for 19 percent. Program setup matters more on OULAD too.
-Methodology note in the amber strip: we use XGBoost on both datasets so the explanations are apples-to-apples. The final selected UCI model is Logistic Regression, and this SHAP comparison is not presented as an explanation of that final UCI model — it explains how signal families shift across datasets. SHAP does not prove causality.
-On the right, the top individual features translate directly into support actions: academic advising, tutoring, financial referral, and engagement outreach. Demographic variables are used for fairness monitoring only, never for punitive action.</a:t>
+              <a:t>This SHAP analysis compares which feature families matter in the two datasets. On UCI, early academic progress contributes about 44 percent of the total SHAP magnitude, followed by financial support at about 20 percent.</a:t>
+            </a:r>
+          </a:p>
+          <a:p xmlns:a="http://schemas.openxmlformats.org/drawingml/2006/main">
+            <a:r>
+              <a:t/>
+            </a:r>
+          </a:p>
+          <a:p xmlns:a="http://schemas.openxmlformats.org/drawingml/2006/main">
+            <a:r>
+              <a:t>On OULAD, early academic progress contributes about 55 percent. Early engagement also contributes about 19 percent, while it is almost absent from UCI because UCI does not contain comparable online activity.</a:t>
+            </a:r>
+          </a:p>
+          <a:p xmlns:a="http://schemas.openxmlformats.org/drawingml/2006/main">
+            <a:r>
+              <a:t/>
+            </a:r>
+          </a:p>
+          <a:p xmlns:a="http://schemas.openxmlformats.org/drawingml/2006/main">
+            <a:r>
+              <a:t>For a fair feature-family comparison, this chart uses XGBoost on both datasets. Therefore, it does not directly explain the selected UCI Logistic Regression model. SHAP describes model associations, not causality. The findings suggest possible support areas such as tutoring, financial referral, and engagement outreach.</a:t>
             </a:r>
           </a:p>
         </p:txBody>
@@ -902,10 +966,37 @@
           <a:lstStyle xmlns:a="http://schemas.openxmlformats.org/drawingml/2006/main"/>
           <a:p xmlns:a="http://schemas.openxmlformats.org/drawingml/2006/main">
             <a:r>
-              <a:t>This slide combines two related pieces of evidence.
-Left: robustness. The chart shows F1 under three stress conditions. Five percent numeric noise barely moves either model — half a point of F1 or less. Ten percent random missingness matters more, especially for UCI: F1 drops from 0.793 to 0.753 and about 5 percent of predictions flip. OULAD is more stable across repeated splits at 0.738 with standard deviation 0.005; UCI is wider at 0.776 with 0.023 because the dataset is smaller.
-Right: error analysis, normalized to 1,000 held-out test observations so the two models are comparable despite very different test-set sizes. UCI gets 263 true positives, 80 false positives, 58 missed, 599 correct rejections; OULAD gets 224, 72, 88, 617.
-The dark strip is the interesting finding. On UCI, missed cases had an average of about six approved units — comparable to Graduate students — versus about two for correctly-identified at-risk cases. On OULAD, missed cases had a submission ratio near 0.89 versus 0.13 for true positives. Missed cases look academically fine on the observed features, so any pilot needs advisor judgement in the loop.</a:t>
+              <a:t>This slide combines robustness and error analysis. Adding five percent numeric noise changed F1 very little. Ten percent random missingness had a larger effect, especially on UCI, where F1 fell from 0.793 to 0.753.</a:t>
+            </a:r>
+          </a:p>
+          <a:p xmlns:a="http://schemas.openxmlformats.org/drawingml/2006/main">
+            <a:r>
+              <a:t/>
+            </a:r>
+          </a:p>
+          <a:p xmlns:a="http://schemas.openxmlformats.org/drawingml/2006/main">
+            <a:r>
+              <a:t>Across repeated splits, OULAD was more stable, with F1 of 0.738 and a standard deviation of 0.005. UCI had more variation because the dataset is smaller.</a:t>
+            </a:r>
+          </a:p>
+          <a:p xmlns:a="http://schemas.openxmlformats.org/drawingml/2006/main">
+            <a:r>
+              <a:t/>
+            </a:r>
+          </a:p>
+          <a:p xmlns:a="http://schemas.openxmlformats.org/drawingml/2006/main">
+            <a:r>
+              <a:t>The right side reports errors per 1,000 test observations. UCI produced 263 true positives and 58 false negatives. OULAD produced 224 true positives and 88 false negatives.</a:t>
+            </a:r>
+          </a:p>
+          <a:p xmlns:a="http://schemas.openxmlformats.org/drawingml/2006/main">
+            <a:r>
+              <a:t/>
+            </a:r>
+          </a:p>
+          <a:p xmlns:a="http://schemas.openxmlformats.org/drawingml/2006/main">
+            <a:r>
+              <a:t>The missed cases often looked lower-risk in the observed data. This is a practical reason to keep advisor judgement in the process.</a:t>
             </a:r>
           </a:p>
         </p:txBody>
@@ -975,9 +1066,27 @@
           <a:lstStyle xmlns:a="http://schemas.openxmlformats.org/drawingml/2006/main"/>
           <a:p xmlns:a="http://schemas.openxmlformats.org/drawingml/2006/main">
             <a:r>
-              <a:t>This is where we translate model output into what advisors would actually experience. The chart on the left shows the four numbers that matter operationally, per 1,000 students: alerts raised, true at-risk identified, false alerts, and missed at-risk cases.
-For UCI, we would raise 344 alerts and correctly find 263 at-risk students; 58 would be missed. For OULAD, 295 alerts, 224 correct, 88 missed. That advisor workload — right-hand card, top — comes to about 13.7 advisor-weeks per 1,000 students on UCI and 11.8 on OULAD, based on a planning assumption of 25 alerts per advisor per week.
-The dark card at the bottom right is a purely illustrative economic sketch. A $100 outreach cost and a $6,000 retained-student value are planning assumptions, not audited institutional numbers. Under those assumptions, retaining just 5-6 additional students per 1,000 would offset the alert cost. But that is not a guaranteed ROI — it depends on whether the advisor intervention actually improves retention, and that has to be tested prospectively.</a:t>
+              <a:t>Here we translate predictions into advisor workload per 1,000 students. The UCI model would raise about 344 alerts and correctly identify 263 at-risk students. The OULAD model would raise about 295 alerts and correctly identify 224.</a:t>
+            </a:r>
+          </a:p>
+          <a:p xmlns:a="http://schemas.openxmlformats.org/drawingml/2006/main">
+            <a:r>
+              <a:t/>
+            </a:r>
+          </a:p>
+          <a:p xmlns:a="http://schemas.openxmlformats.org/drawingml/2006/main">
+            <a:r>
+              <a:t>Using a planning capacity of 25 alerts per advisor per week, this equals about 13.7 advisor-weeks for UCI and 11.8 for OULAD.</a:t>
+            </a:r>
+          </a:p>
+          <a:p xmlns:a="http://schemas.openxmlformats.org/drawingml/2006/main">
+            <a:r>
+              <a:t/>
+            </a:r>
+          </a:p>
+          <a:p xmlns:a="http://schemas.openxmlformats.org/drawingml/2006/main">
+            <a:r>
+              <a:t>The economic example is illustrative, not an observed return on investment. We assumed a 100-dollar outreach cost and a 6,000-dollar value for retaining one student. Under those assumptions, retaining about five or six additional students would offset the alert cost. The real effect must be measured in a pilot.</a:t>
             </a:r>
           </a:p>
         </p:txBody>
@@ -1047,11 +1156,47 @@
           <a:lstStyle xmlns:a="http://schemas.openxmlformats.org/drawingml/2006/main"/>
           <a:p xmlns:a="http://schemas.openxmlformats.org/drawingml/2006/main">
             <a:r>
-              <a:t>Four caveats we would state clearly to any faculty audience before recommending action.
-Top left, external comparability. Our OULAD model predicts Withdrawn versus everything else using the first 75 days. The commonly-referenced GitHub project uses roughly the first 14 days, drops Withdrawn students entirely from its dataset, and effectively predicts Fail versus Pass or Distinction. So our numbers cannot be ranked head-to-head against theirs — different target definitions, different windows, different populations. Citations [7] and [8] in the appendix.
-Top right, data quality. UCI is complete and Enrolled students stay in the non-dropout class — that is a data reality, not a design choice we made to hide anything. But our 10 percent MCAR simulation shows how institutional data quality could realistically degrade performance.
-Bottom left, fairness. Risk scores are probabilities. Use them for support outreach, monitor subgroup recall, restrict access.
-Bottom right, scope. Two public datasets are not every institution. Feature semantics do not travel, and any new institution should re-train and re-calibrate — never re-use these weights directly.</a:t>
+              <a:t>Before recommending a pilot, we would state four limitations.</a:t>
+            </a:r>
+          </a:p>
+          <a:p xmlns:a="http://schemas.openxmlformats.org/drawingml/2006/main">
+            <a:r>
+              <a:t/>
+            </a:r>
+          </a:p>
+          <a:p xmlns:a="http://schemas.openxmlformats.org/drawingml/2006/main">
+            <a:r>
+              <a:t>First, external performance numbers are not directly comparable when studies use different targets and observation windows. Our OULAD model predicts Withdrawn using 75 days, while the referenced implementation uses a different population and a much earlier window.</a:t>
+            </a:r>
+          </a:p>
+          <a:p xmlns:a="http://schemas.openxmlformats.org/drawingml/2006/main">
+            <a:r>
+              <a:t/>
+            </a:r>
+          </a:p>
+          <a:p xmlns:a="http://schemas.openxmlformats.org/drawingml/2006/main">
+            <a:r>
+              <a:t>Second, institutional data may be less complete than these public datasets. Our missingness test shows that data quality can reduce performance.</a:t>
+            </a:r>
+          </a:p>
+          <a:p xmlns:a="http://schemas.openxmlformats.org/drawingml/2006/main">
+            <a:r>
+              <a:t/>
+            </a:r>
+          </a:p>
+          <a:p xmlns:a="http://schemas.openxmlformats.org/drawingml/2006/main">
+            <a:r>
+              <a:t>Third, risk scores should be used for supportive outreach, with access controls and subgroup recall monitoring.</a:t>
+            </a:r>
+          </a:p>
+          <a:p xmlns:a="http://schemas.openxmlformats.org/drawingml/2006/main">
+            <a:r>
+              <a:t/>
+            </a:r>
+          </a:p>
+          <a:p xmlns:a="http://schemas.openxmlformats.org/drawingml/2006/main">
+            <a:r>
+              <a:t>Finally, results from two public datasets may not transfer to another institution. A new institution should retrain and recalibrate the model rather than reuse our fitted weights.</a:t>
             </a:r>
           </a:p>
         </p:txBody>
@@ -1121,10 +1266,27 @@
           <a:lstStyle xmlns:a="http://schemas.openxmlformats.org/drawingml/2006/main"/>
           <a:p xmlns:a="http://schemas.openxmlformats.org/drawingml/2006/main">
             <a:r>
-              <a:t>The top timeline is a proposed pilot — not something that is currently deployed. Four phases across four terms: prepare the data pipeline, run silently in shadow, launch a limited advisor-facing pilot on one or two modules, and then review, retrain, and decide whether to expand scope.
-Left column: what we would monitor weekly during the pilot. Alert volume, precision and recall drift, subgroup recall, score-distribution shift, and advisor overrides.
-Middle column: retrain cadence is term-scoped, with rollback if metrics regress and version-controlled model and data snapshots for audit.
-Right column: future work. The most important item is the last one — evaluating the intervention, not just the prediction. Getting the model right is only half the problem; whether the advisor action actually improves retention has to be measured prospectively.</a:t>
+              <a:t>Our proposed deployment starts with preparation, followed by silent or shadow scoring. After that, a limited advisor-facing pilot could run in one or two modules. The final phase would review outcomes and decide whether to expand.</a:t>
+            </a:r>
+          </a:p>
+          <a:p xmlns:a="http://schemas.openxmlformats.org/drawingml/2006/main">
+            <a:r>
+              <a:t/>
+            </a:r>
+          </a:p>
+          <a:p xmlns:a="http://schemas.openxmlformats.org/drawingml/2006/main">
+            <a:r>
+              <a:t>During the pilot, we would monitor alert volume, precision and recall, subgroup recall, score drift, and advisor overrides. Retraining would happen by academic term, with versioned data and model records.</a:t>
+            </a:r>
+          </a:p>
+          <a:p xmlns:a="http://schemas.openxmlformats.org/drawingml/2006/main">
+            <a:r>
+              <a:t/>
+            </a:r>
+          </a:p>
+          <a:p xmlns:a="http://schemas.openxmlformats.org/drawingml/2006/main">
+            <a:r>
+              <a:t>The most important future step is to evaluate the intervention itself. A model can identify risk, but only a prospective pilot can show whether advisor support changes student outcomes.</a:t>
             </a:r>
           </a:p>
         </p:txBody>
@@ -1194,7 +1356,7 @@
           <a:lstStyle xmlns:a="http://schemas.openxmlformats.org/drawingml/2006/main"/>
           <a:p xmlns:a="http://schemas.openxmlformats.org/drawingml/2006/main">
             <a:r>
-              <a:t>Three takeaways, plus one clear statement of the project contribution.</a:t>
+              <a:t>Our contribution is not a new algorithm. It is a common, leakage-aware framework that compares timing, feature families, robustness, and advisor workload across two different educational datasets.</a:t>
             </a:r>
           </a:p>
           <a:p xmlns:a="http://schemas.openxmlformats.org/drawingml/2006/main">
@@ -1204,7 +1366,7 @@
           </a:p>
           <a:p xmlns:a="http://schemas.openxmlformats.org/drawingml/2006/main">
             <a:r>
-              <a:t>The contribution is a common leakage-aware evaluation framework that compares early-warning timing, feature-family shifts, robustness, and advisor workload across UCI and OULAD. It is a comparative applied contribution rather than a new machine-learning algorithm.</a:t>
+              <a:t>There are three main takeaways.</a:t>
             </a:r>
           </a:p>
           <a:p xmlns:a="http://schemas.openxmlformats.org/drawingml/2006/main">
@@ -1214,7 +1376,7 @@
           </a:p>
           <a:p xmlns:a="http://schemas.openxmlformats.org/drawingml/2006/main">
             <a:r>
-              <a:t>First, the useful signals change across educational contexts. UCI relies more on academic and financial records, while OULAD relies more on assessment progress, engagement, and program context. We compared the contexts but did not directly transfer one trained model to the other dataset.</a:t>
+              <a:t>First, useful signals depend on context. UCI relies more on academic and financial records, while OULAD adds assessment and engagement behaviour.</a:t>
             </a:r>
           </a:p>
           <a:p xmlns:a="http://schemas.openxmlformats.org/drawingml/2006/main">
@@ -1224,7 +1386,7 @@
           </a:p>
           <a:p xmlns:a="http://schemas.openxmlformats.org/drawingml/2006/main">
             <a:r>
-              <a:t>Second, the timing experiment shows a practical trade-off. OULAD F1 rises from 0.682 at day 35 to 0.738 at day 75, but waiting for more data reduces the time available for intervention. This timing decision is more operationally important than the small gains from hyperparameter tuning.</a:t>
+              <a:t>Second, timing matters. OULAD F1 rises from 0.682 at day 35 to 0.738 at day 75, but the later window leaves less time for intervention.</a:t>
             </a:r>
           </a:p>
           <a:p xmlns:a="http://schemas.openxmlformats.org/drawingml/2006/main">
@@ -1234,7 +1396,7 @@
           </a:p>
           <a:p xmlns:a="http://schemas.openxmlformats.org/drawingml/2006/main">
             <a:r>
-              <a:t>Third, prediction is only the first step. The datasets do not show whether a particular advisor intervention causes better retention. That question requires prospective evaluation in a controlled pilot.</a:t>
+              <a:t>Third, prediction is only the first step. These historical datasets cannot show that an intervention causes better retention. That question requires a controlled, prospective pilot.</a:t>
             </a:r>
           </a:p>
         </p:txBody>
@@ -1304,8 +1466,7 @@
           <a:lstStyle xmlns:a="http://schemas.openxmlformats.org/drawingml/2006/main"/>
           <a:p xmlns:a="http://schemas.openxmlformats.org/drawingml/2006/main">
             <a:r>
-              <a:t>We're happy to take questions. Suggested topics on the slide — methodology, threshold choice, explainability, fairness, pilot assumptions, and limitations — but genuinely open to anything.
-Thank you.</a:t>
+              <a:t>That concludes our presentation. Thank you for listening. We are happy to answer questions about the data, modelling choices, timing experiment, SHAP analysis, limitations, or proposed pilot.</a:t>
             </a:r>
           </a:p>
         </p:txBody>
@@ -1375,7 +1536,7 @@
           <a:lstStyle xmlns:a="http://schemas.openxmlformats.org/drawingml/2006/main"/>
           <a:p xmlns:a="http://schemas.openxmlformats.org/drawingml/2006/main">
             <a:r>
-              <a:t/>
+              <a:t>Appendix slide. Do not present this slide unless a question requires the detailed assumptions or evaluation criteria. Use the left column for model-holding criteria and the right column for evidence required before recommending a pilot.</a:t>
             </a:r>
           </a:p>
         </p:txBody>
@@ -1445,7 +1606,17 @@
           <a:lstStyle xmlns:a="http://schemas.openxmlformats.org/drawingml/2006/main"/>
           <a:p xmlns:a="http://schemas.openxmlformats.org/drawingml/2006/main">
             <a:r>
-              <a:t>Ten sections, following Activity 7 order. Data and EDA remains the largest block at four minutes across three slides because the professor asked us to explain the data in more detail. Methodology is kept to three minutes. Results now take four minutes and include held-out performance, the timing trade-off, SHAP, and robustness. Detailed assumptions remain in the appendix. Total: 18 spoken slides plus two appendix slides.</a:t>
+              <a:t>This is the structure of the presentation. We will begin with the problem and the two datasets. We will then spend the largest section on data exploration, followed by methodology and model results.</a:t>
+            </a:r>
+          </a:p>
+          <a:p xmlns:a="http://schemas.openxmlformats.org/drawingml/2006/main">
+            <a:r>
+              <a:t/>
+            </a:r>
+          </a:p>
+          <a:p xmlns:a="http://schemas.openxmlformats.org/drawingml/2006/main">
+            <a:r>
+              <a:t>After that, we will discuss practical impact, limitations, a possible pilot plan, and our main takeaways. The presentation is planned for about 20 minutes, followed by questions.</a:t>
             </a:r>
           </a:p>
         </p:txBody>
@@ -1515,7 +1686,7 @@
           <a:lstStyle xmlns:a="http://schemas.openxmlformats.org/drawingml/2006/main"/>
           <a:p xmlns:a="http://schemas.openxmlformats.org/drawingml/2006/main">
             <a:r>
-              <a:t/>
+              <a:t>Reference slide. Do not read this slide during the main presentation. Use it only to identify the base paper, datasets, software documentation, or external OULAD comparisons during questions.</a:t>
             </a:r>
           </a:p>
         </p:txBody>
@@ -1585,9 +1756,17 @@
           <a:lstStyle xmlns:a="http://schemas.openxmlformats.org/drawingml/2006/main"/>
           <a:p xmlns:a="http://schemas.openxmlformats.org/drawingml/2006/main">
             <a:r>
-              <a:t>Institutions collect a lot of information about students very early — grades, tuition status, engagement logs — but withdrawal decisions are often only acted on after the fact. That is the gap we are trying to close.
-Our specific objective, in the highlighted card, is to reproduce a published UCI early-warning approach and then apply the same leakage-aware workflow separately to OULAD, which is a very different behavioural dataset. We compare how the two settings behave — we do not train on one and test on the other, so this is a cross-context evaluation, not a transfer test.
-The dark right-hand panel gives you the scale: 4,424 records in UCI and 32,593 student-module rows in OULAD, evaluated within the first 75 days on OULAD and using first-semester curricular units on UCI. The output we deliver is a decision-support prototype and a proposed pilot plan, not an operational system.</a:t>
+              <a:t>Higher-education institutions collect useful information early, including grades, tuition status, and online engagement. However, withdrawal is often addressed only after a student has already disengaged. Our goal is to identify risk earlier, when support may still be useful.</a:t>
+            </a:r>
+          </a:p>
+          <a:p xmlns:a="http://schemas.openxmlformats.org/drawingml/2006/main">
+            <a:r>
+              <a:t/>
+            </a:r>
+          </a:p>
+          <a:p xmlns:a="http://schemas.openxmlformats.org/drawingml/2006/main">
+            <a:r>
+              <a:t>We used 4,424 UCI records and 32,593 OULAD student-module records. For OULAD, prediction features were limited to the first 75 days. Our output is a decision-support prototype and a proposed pilot plan. It is not a deployed institutional system.</a:t>
             </a:r>
           </a:p>
         </p:txBody>
@@ -1657,11 +1836,27 @@
           <a:lstStyle xmlns:a="http://schemas.openxmlformats.org/drawingml/2006/main"/>
           <a:p xmlns:a="http://schemas.openxmlformats.org/drawingml/2006/main">
             <a:r>
-              <a:t>The business problem in one line: advisors want to identify at-risk students earlier and more consistently. Three bullets on the left summarise why manual review alone is not enough.
-Stakeholders are on the left card. Students first — they are the people the model is about. Then academic advisors, student-success offices, and IT/data-governance teams, because any pilot would run through them.
-Constraints matter and I want to be honest about them: we worked from public historical datasets only, with no access to a live SIS or LMS, on limited local compute, and — critically — we have no causal evidence that advisor interventions actually improve retention. That constraint is why we recommend evaluating in a pilot rather than deploying.
-On the right, the translation to a supervised binary classification task with dataset-specific target definitions. UCI predicts Dropout versus Enrolled or Graduate. OULAD predicts Withdrawn versus Pass, Distinction, or Fail.
-The bottom strip lists the four kinds of evidence we look at — statistical, operational, fairness, robustness — before recommending anything.</a:t>
+              <a:t>The business question is simple: how can advisors identify at-risk students earlier and more consistently? We translated this into binary classification.</a:t>
+            </a:r>
+          </a:p>
+          <a:p xmlns:a="http://schemas.openxmlformats.org/drawingml/2006/main">
+            <a:r>
+              <a:t/>
+            </a:r>
+          </a:p>
+          <a:p xmlns:a="http://schemas.openxmlformats.org/drawingml/2006/main">
+            <a:r>
+              <a:t>For UCI, the positive class is Dropout. Enrolled and Graduate are the comparison class. For OULAD, the positive class is Withdrawn, while Pass, Distinction, and Fail form the comparison class.</a:t>
+            </a:r>
+          </a:p>
+          <a:p xmlns:a="http://schemas.openxmlformats.org/drawingml/2006/main">
+            <a:r>
+              <a:t/>
+            </a:r>
+          </a:p>
+          <a:p xmlns:a="http://schemas.openxmlformats.org/drawingml/2006/main">
+            <a:r>
+              <a:t>The main users would be students, advisors, student-success teams, and data-governance staff. We also worked under important constraints: public historical data, no live student system, limited local computing resources, and no causal evidence that an intervention improves retention. These limits are why we recommend a pilot, not full deployment.</a:t>
             </a:r>
           </a:p>
         </p:txBody>
@@ -1731,10 +1926,27 @@
           <a:lstStyle xmlns:a="http://schemas.openxmlformats.org/drawingml/2006/main"/>
           <a:p xmlns:a="http://schemas.openxmlformats.org/drawingml/2006/main">
             <a:r>
-              <a:t>First of three EDA slides — the data profile.
-Class balance is comparable across the two datasets — about a third dropout on UCI, about a third withdrawn on OULAD. Manageable with class-weight adjustment rather than resampling.
-The dark strip is the important part on this slide. On UCI: zero missing values, zero duplicate rows. Enrolled stays in the non-dropout class of the binary task — it is a valid outcome, not a hidden missing bucket. On the OULAD final modelling table: zero duplicate rows; imd_band has 3.41 percent missing values, and date_registration and registration_lead_days each have 0.14 percent missing. Everything else is complete on this table.
-On the right, how we handled it. Missing values are handled inside the modelling pipeline — imputation happens after the train/validation/test split so nothing leaks. Numeric outliers were not deleted; they were clipped at the 1st and 99th percentiles, and those percentile thresholds were estimated from training data only.</a:t>
+              <a:t>This slide gives the basic data profile. The class balance is similar in both datasets: roughly one third of UCI students are labelled Dropout, and roughly one third of OULAD records are Withdrawn. We handled this with class weights rather than resampling.</a:t>
+            </a:r>
+          </a:p>
+          <a:p xmlns:a="http://schemas.openxmlformats.org/drawingml/2006/main">
+            <a:r>
+              <a:t/>
+            </a:r>
+          </a:p>
+          <a:p xmlns:a="http://schemas.openxmlformats.org/drawingml/2006/main">
+            <a:r>
+              <a:t>UCI has no missing values or duplicate rows. In the final OULAD modelling table, duplicate rows are also zero. The main missing field is the area deprivation band, at about 3.4 percent. Registration-date fields have about 0.14 percent missingness.</a:t>
+            </a:r>
+          </a:p>
+          <a:p xmlns:a="http://schemas.openxmlformats.org/drawingml/2006/main">
+            <a:r>
+              <a:t/>
+            </a:r>
+          </a:p>
+          <a:p xmlns:a="http://schemas.openxmlformats.org/drawingml/2006/main">
+            <a:r>
+              <a:t>Imputation happens inside the modelling pipeline after the data split. Numeric outliers are clipped using the first and ninety-ninth percentiles estimated from training data only. This prevents information leakage.</a:t>
             </a:r>
           </a:p>
         </p:txBody>
@@ -1804,10 +2016,27 @@
           <a:lstStyle xmlns:a="http://schemas.openxmlformats.org/drawingml/2006/main"/>
           <a:p xmlns:a="http://schemas.openxmlformats.org/drawingml/2006/main">
             <a:r>
-              <a:t>Second EDA slide, focused on UCI.
-Left chart: first-semester approved units broken out by final outcome. The pattern is clear — Dropout students have a median of about two approved units, while Graduate students have about six. Enrolled students sit in between. This is the single strongest exploratory signal on UCI, and it drives most of what the model later learns.
-Right chart: a correlation heatmap over selected numeric variables. Explicitly labelled as exploratory — correlation is not causation. Two things are visible. First, first-semester and second-semester academic variables are very strongly correlated, around 0.9. That is a leakage risk for an early-warning model, because second-semester data would not be available at the moment we want to predict. Second, macroeconomic variables — unemployment, inflation, GDP — correlate weakly with academic variables, so we did not expect them to carry much predictive weight.
-Modelling implication, in the dark strip: we retained first-semester variables and removed second-semester variables. That is a deliberate leakage-prevention choice, not an accuracy trade-off.</a:t>
+              <a:t>This is the UCI exploratory analysis. On the left, dropout students completed fewer first-semester curricular units. Their median is about two approved units, compared with about six for graduate students. Enrolled students fall between those groups.</a:t>
+            </a:r>
+          </a:p>
+          <a:p xmlns:a="http://schemas.openxmlformats.org/drawingml/2006/main">
+            <a:r>
+              <a:t/>
+            </a:r>
+          </a:p>
+          <a:p xmlns:a="http://schemas.openxmlformats.org/drawingml/2006/main">
+            <a:r>
+              <a:t>The heatmap on the right shows that first- and second-semester academic variables are strongly correlated. Since second-semester information would not be available at an early prediction point, using it would create leakage.</a:t>
+            </a:r>
+          </a:p>
+          <a:p xmlns:a="http://schemas.openxmlformats.org/drawingml/2006/main">
+            <a:r>
+              <a:t/>
+            </a:r>
+          </a:p>
+          <a:p xmlns:a="http://schemas.openxmlformats.org/drawingml/2006/main">
+            <a:r>
+              <a:t>For that reason, we retained first-semester variables and removed second-semester variables. The exploratory relationship is strong, but it should not be interpreted as causal.</a:t>
             </a:r>
           </a:p>
         </p:txBody>
@@ -1877,11 +2106,27 @@
           <a:lstStyle xmlns:a="http://schemas.openxmlformats.org/drawingml/2006/main"/>
           <a:p xmlns:a="http://schemas.openxmlformats.org/drawingml/2006/main">
             <a:r>
-              <a:t>Third EDA slide, focused on OULAD.
-Left chart: log-transformed Virtual Learning Environment click counts, broken out by final result. Withdrawn students cluster at the low end — many at effectively zero activity. Pass and especially Distinction students cluster much higher.
-Right chart: mean assessment score by final result. Distinction students separate cleanly at the high end. Withdrawn students have a wide distribution that reaches all the way down to zero. Important methodological point in the amber note: students without recorded assessment activity were coded as zero for this descriptive EDA. Those zeros represent no recorded activity — they may include students who did not submit assessments at all. We do not claim they definitely stopped submitting; we only observe that no activity was recorded.
-Two things to notice. First, the association is real but noisy — distributions overlap heavily, so no single measure is enough on its own. That is why we build a combined feature set rather than relying on one signal. Second, and important: this EDA looks at full-course patterns to identify candidate signals. The predictive model itself uses only activity from the first 75 days — otherwise it would leak information from the future into the prediction moment.
-Modelling implication, in the dark strip: these patterns motivated the early assessment and VLE engagement features that show up as the strongest signals in the SHAP analysis later.</a:t>
+              <a:t>This slide shows the OULAD exploratory analysis. On the left, withdrawn students generally have fewer virtual learning environment clicks. Pass and Distinction students tend to show more activity.</a:t>
+            </a:r>
+          </a:p>
+          <a:p xmlns:a="http://schemas.openxmlformats.org/drawingml/2006/main">
+            <a:r>
+              <a:t/>
+            </a:r>
+          </a:p>
+          <a:p xmlns:a="http://schemas.openxmlformats.org/drawingml/2006/main">
+            <a:r>
+              <a:t>On the right, withdrawn students also have lower and more variable assessment scores. Students with no recorded assessment activity are shown as zero for this descriptive chart. That means no activity was recorded; it does not prove why the activity is missing.</a:t>
+            </a:r>
+          </a:p>
+          <a:p xmlns:a="http://schemas.openxmlformats.org/drawingml/2006/main">
+            <a:r>
+              <a:t/>
+            </a:r>
+          </a:p>
+          <a:p xmlns:a="http://schemas.openxmlformats.org/drawingml/2006/main">
+            <a:r>
+              <a:t>These groups still overlap, so one measure is not enough by itself. Also, this EDA uses full-course information only to identify possible signals. The predictive model uses activity available within the first 75 days. This distinction prevents future information from entering the model.</a:t>
             </a:r>
           </a:p>
         </p:txBody>
@@ -1951,11 +2196,37 @@
           <a:lstStyle xmlns:a="http://schemas.openxmlformats.org/drawingml/2006/main"/>
           <a:p xmlns:a="http://schemas.openxmlformats.org/drawingml/2006/main">
             <a:r>
-              <a:t>Same pipeline runs twice, once per dataset. Six steps.
-Step 1 is data prep — we remove leakage-prone columns, build the binary target, and take a stratified 60/20/20 split. Step 2 is feature engineering: one-hot encoding, standard scaling, and on OULAD, restricting behavioural features to the first 75 days.
-Steps 3 and 4: we evaluated Decision Tree, Random Forest, Gradient Boosting, Logistic Regression, and XGBoost as baselines, then focused hyperparameter tuning on the two that were consistently strongest. Selection happens on the validation split with F1 or macro-F1 as the objective. Five-fold cross-validation summaries were computed afterwards, as stability evidence — not for selection.
-Step 5: we tune the classification threshold on validation F1, and use recall and balanced accuracy as tie-breakers. Step 6: the test set stays untouched until the final model is locked, and only then do we compute SHAP and run robustness checks.
-On the bottom left: why Logistic Regression on UCI and XGBoost on OULAD. UCI's signal is mostly linear, so LogReg matches XGBoost while staying interpretable. OULAD has non-linear interactions between clicks and submission ratios, and XGBoost was consistently ahead.</a:t>
+              <a:t>We ran the same six-step workflow separately on each dataset. First, we removed leakage-prone columns, created the binary target, and made a stratified 60, 20, 20 split for training, validation, and testing.</a:t>
+            </a:r>
+          </a:p>
+          <a:p xmlns:a="http://schemas.openxmlformats.org/drawingml/2006/main">
+            <a:r>
+              <a:t/>
+            </a:r>
+          </a:p>
+          <a:p xmlns:a="http://schemas.openxmlformats.org/drawingml/2006/main">
+            <a:r>
+              <a:t>Next, we encoded categorical variables, scaled numeric variables where needed, and created OULAD behavioural features using only the allowed observation window.</a:t>
+            </a:r>
+          </a:p>
+          <a:p xmlns:a="http://schemas.openxmlformats.org/drawingml/2006/main">
+            <a:r>
+              <a:t/>
+            </a:r>
+          </a:p>
+          <a:p xmlns:a="http://schemas.openxmlformats.org/drawingml/2006/main">
+            <a:r>
+              <a:t>We compared five baseline models, then tuned the strongest candidates using validation F1. Classification thresholds were also selected on the validation set. The test set remained untouched until the model and threshold were fixed.</a:t>
+            </a:r>
+          </a:p>
+          <a:p xmlns:a="http://schemas.openxmlformats.org/drawingml/2006/main">
+            <a:r>
+              <a:t/>
+            </a:r>
+          </a:p>
+          <a:p xmlns:a="http://schemas.openxmlformats.org/drawingml/2006/main">
+            <a:r>
+              <a:t>Logistic Regression was selected for UCI because it performed well with a mostly linear signal. XGBoost was selected for OULAD because it captured interactions between assessments and engagement.</a:t>
             </a:r>
           </a:p>
         </p:txBody>
@@ -2025,9 +2296,27 @@
           <a:lstStyle xmlns:a="http://schemas.openxmlformats.org/drawingml/2006/main"/>
           <a:p xmlns:a="http://schemas.openxmlformats.org/drawingml/2006/main">
             <a:r>
-              <a:t>Two decisions rolled onto one slide: hyperparameter tuning and threshold selection.
-Left table: baseline versus tuned F1 on the held-out test set. Two of the four tuned runs improved. UCI Logistic Regression moved from 0.783 to 0.793, OULAD XGBoost from 0.729 to 0.738. UCI binary XGBoost and the multiclass reproduction task regressed — so we did not carry the multiclass version forward. All changes are small (about one F1 point) and we have not shown them statistically significant.
-Below the table, threshold selection — which we do on the validation set only. The three cutoffs, 0.50, 0.46, and 0.60, were each picked as the value that maximised validation F1, then applied once on the held-out test set. The right-hand chart shows the OULAD threshold sweep on validation; F1 peaks near 0.60. Bottom right lists the winning hyperparameter settings — all narrow grids, depth under 6, learning rate at 0.07 or below.</a:t>
+              <a:t>This slide separates tuning from threshold selection. The table reports baseline and tuned performance on the final test set. UCI Logistic Regression improved from 0.783 to 0.793 F1. OULAD XGBoost improved from 0.729 to 0.738.</a:t>
+            </a:r>
+          </a:p>
+          <a:p xmlns:a="http://schemas.openxmlformats.org/drawingml/2006/main">
+            <a:r>
+              <a:t/>
+            </a:r>
+          </a:p>
+          <a:p xmlns:a="http://schemas.openxmlformats.org/drawingml/2006/main">
+            <a:r>
+              <a:t>However, two other tuned models became slightly worse. This shows that tuning does not guarantee improvement, especially when the search is narrow and the validation sample is limited.</a:t>
+            </a:r>
+          </a:p>
+          <a:p xmlns:a="http://schemas.openxmlformats.org/drawingml/2006/main">
+            <a:r>
+              <a:t/>
+            </a:r>
+          </a:p>
+          <a:p xmlns:a="http://schemas.openxmlformats.org/drawingml/2006/main">
+            <a:r>
+              <a:t>The thresholds were chosen using validation data only. The selected values were 0.50 for UCI Logistic Regression, 0.46 for UCI XGBoost, and 0.60 for OULAD XGBoost. The gains are modest, so we do not claim that tuning created a major breakthrough.</a:t>
             </a:r>
           </a:p>
         </p:txBody>
@@ -2095,7 +2384,7 @@
   </p:cSld>
   <p:clrMap bg1="lt1" tx1="dk1" bg2="lt2" tx2="dk2" accent1="accent1" accent2="accent2" accent3="accent3" accent4="accent4" accent5="accent5" accent6="accent6" hlink="hlink" folHlink="folHlink"/>
   <p:sldLayoutIdLst>
-    <p:sldLayoutId xmlns:r="http://schemas.openxmlformats.org/officeDocument/2006/relationships" id="2147483649" r:id="Rd475feb81018484d"/>
+    <p:sldLayoutId xmlns:r="http://schemas.openxmlformats.org/officeDocument/2006/relationships" id="2147483649" r:id="Rfb74a5a8f0b0427a"/>
   </p:sldLayoutIdLst>
   <p:hf sldNum="0" hdr="0" ftr="0" dt="0"/>
   <p:txStyles>
@@ -2670,7 +2959,7 @@
           <p:nvPr/>
         </p:nvPicPr>
         <p:blipFill>
-          <a:blip xmlns:r="http://schemas.openxmlformats.org/officeDocument/2006/relationships" xmlns:a="http://schemas.openxmlformats.org/drawingml/2006/main" r:embed="R8c93230f28824bb3"/>
+          <a:blip xmlns:r="http://schemas.openxmlformats.org/officeDocument/2006/relationships" xmlns:a="http://schemas.openxmlformats.org/drawingml/2006/main" r:embed="Rc69584a50cbd4ff7"/>
           <a:srcRect xmlns:a="http://schemas.openxmlformats.org/drawingml/2006/main" l="-2" t="0" r="-2" b="0"/>
           <a:stretch xmlns:a="http://schemas.openxmlformats.org/drawingml/2006/main"/>
         </p:blipFill>
@@ -2693,7 +2982,7 @@
           <p:nvPr/>
         </p:nvPicPr>
         <p:blipFill>
-          <a:blip xmlns:r="http://schemas.openxmlformats.org/officeDocument/2006/relationships" xmlns:a="http://schemas.openxmlformats.org/drawingml/2006/main" r:embed="R1bcf445f9e9346c9"/>
+          <a:blip xmlns:r="http://schemas.openxmlformats.org/officeDocument/2006/relationships" xmlns:a="http://schemas.openxmlformats.org/drawingml/2006/main" r:embed="R87d0f531c39840a0"/>
           <a:srcRect xmlns:a="http://schemas.openxmlformats.org/drawingml/2006/main" l="0" t="-201" r="0" b="-201"/>
           <a:stretch xmlns:a="http://schemas.openxmlformats.org/drawingml/2006/main"/>
         </p:blipFill>
@@ -2856,7 +3145,7 @@
           <p:nvPr/>
         </p:nvPicPr>
         <p:blipFill>
-          <a:blip xmlns:r="http://schemas.openxmlformats.org/officeDocument/2006/relationships" xmlns:a="http://schemas.openxmlformats.org/drawingml/2006/main" r:embed="R94f4655ccd694de3"/>
+          <a:blip xmlns:r="http://schemas.openxmlformats.org/officeDocument/2006/relationships" xmlns:a="http://schemas.openxmlformats.org/drawingml/2006/main" r:embed="Rf53a957bdb594edf"/>
           <a:srcRect xmlns:a="http://schemas.openxmlformats.org/drawingml/2006/main" l="0" t="-2100" r="0" b="-2100"/>
           <a:stretch xmlns:a="http://schemas.openxmlformats.org/drawingml/2006/main"/>
         </p:blipFill>
@@ -2879,7 +3168,7 @@
           <p:nvPr/>
         </p:nvPicPr>
         <p:blipFill>
-          <a:blip xmlns:r="http://schemas.openxmlformats.org/officeDocument/2006/relationships" xmlns:a="http://schemas.openxmlformats.org/drawingml/2006/main" r:embed="R004619a8f5e44718"/>
+          <a:blip xmlns:r="http://schemas.openxmlformats.org/officeDocument/2006/relationships" xmlns:a="http://schemas.openxmlformats.org/drawingml/2006/main" r:embed="R22a9c92230a14733"/>
           <a:srcRect xmlns:a="http://schemas.openxmlformats.org/drawingml/2006/main" l="-2083" t="0" r="-2083" b="0"/>
           <a:stretch xmlns:a="http://schemas.openxmlformats.org/drawingml/2006/main"/>
         </p:blipFill>
@@ -4411,7 +4700,7 @@
           <p:nvPr/>
         </p:nvPicPr>
         <p:blipFill>
-          <a:blip xmlns:r="http://schemas.openxmlformats.org/officeDocument/2006/relationships" xmlns:a="http://schemas.openxmlformats.org/drawingml/2006/main" r:embed="Rf1a0ca1b13a144ce"/>
+          <a:blip xmlns:r="http://schemas.openxmlformats.org/officeDocument/2006/relationships" xmlns:a="http://schemas.openxmlformats.org/drawingml/2006/main" r:embed="Rd4e0d316da974149"/>
           <a:srcRect xmlns:a="http://schemas.openxmlformats.org/drawingml/2006/main" l="-2083" t="0" r="-2083" b="0"/>
           <a:stretch xmlns:a="http://schemas.openxmlformats.org/drawingml/2006/main"/>
         </p:blipFill>
@@ -4613,7 +4902,7 @@
           <p:nvPr/>
         </p:nvPicPr>
         <p:blipFill>
-          <a:blip xmlns:r="http://schemas.openxmlformats.org/officeDocument/2006/relationships" xmlns:a="http://schemas.openxmlformats.org/drawingml/2006/main" r:embed="R47fc8cdb14a24056"/>
+          <a:blip xmlns:r="http://schemas.openxmlformats.org/officeDocument/2006/relationships" xmlns:a="http://schemas.openxmlformats.org/drawingml/2006/main" r:embed="R12ba2ad2fff84ec3"/>
           <a:srcRect xmlns:a="http://schemas.openxmlformats.org/drawingml/2006/main" l="-2614" t="0" r="-2614" b="0"/>
           <a:stretch xmlns:a="http://schemas.openxmlformats.org/drawingml/2006/main"/>
         </p:blipFill>
@@ -5815,7 +6104,7 @@
           <p:nvPr/>
         </p:nvPicPr>
         <p:blipFill>
-          <a:blip xmlns:r="http://schemas.openxmlformats.org/officeDocument/2006/relationships" xmlns:a="http://schemas.openxmlformats.org/drawingml/2006/main" r:embed="Rd434549b998a4b14"/>
+          <a:blip xmlns:r="http://schemas.openxmlformats.org/officeDocument/2006/relationships" xmlns:a="http://schemas.openxmlformats.org/drawingml/2006/main" r:embed="Rac644918f36f44fd"/>
           <a:srcRect xmlns:a="http://schemas.openxmlformats.org/drawingml/2006/main" l="-2083" t="0" r="-2083" b="0"/>
           <a:stretch xmlns:a="http://schemas.openxmlformats.org/drawingml/2006/main"/>
         </p:blipFill>
@@ -6089,7 +6378,7 @@
           <p:nvPr/>
         </p:nvPicPr>
         <p:blipFill>
-          <a:blip xmlns:r="http://schemas.openxmlformats.org/officeDocument/2006/relationships" xmlns:a="http://schemas.openxmlformats.org/drawingml/2006/main" r:embed="R2adde478733142cf"/>
+          <a:blip xmlns:r="http://schemas.openxmlformats.org/officeDocument/2006/relationships" xmlns:a="http://schemas.openxmlformats.org/drawingml/2006/main" r:embed="R2d2b42f369bf4b8c"/>
           <a:srcRect xmlns:a="http://schemas.openxmlformats.org/drawingml/2006/main" l="-3900" t="0" r="-3900" b="0"/>
           <a:stretch xmlns:a="http://schemas.openxmlformats.org/drawingml/2006/main"/>
         </p:blipFill>
@@ -7056,7 +7345,7 @@
           <p:nvPr/>
         </p:nvPicPr>
         <p:blipFill>
-          <a:blip xmlns:r="http://schemas.openxmlformats.org/officeDocument/2006/relationships" xmlns:a="http://schemas.openxmlformats.org/drawingml/2006/main" r:embed="R0518cb48eee444b6"/>
+          <a:blip xmlns:r="http://schemas.openxmlformats.org/officeDocument/2006/relationships" xmlns:a="http://schemas.openxmlformats.org/drawingml/2006/main" r:embed="R842d04fdceab4719"/>
           <a:srcRect xmlns:a="http://schemas.openxmlformats.org/drawingml/2006/main" l="-2083" t="0" r="-2083" b="0"/>
           <a:stretch xmlns:a="http://schemas.openxmlformats.org/drawingml/2006/main"/>
         </p:blipFill>
@@ -7330,7 +7619,7 @@
           <p:nvPr/>
         </p:nvPicPr>
         <p:blipFill>
-          <a:blip xmlns:r="http://schemas.openxmlformats.org/officeDocument/2006/relationships" xmlns:a="http://schemas.openxmlformats.org/drawingml/2006/main" r:embed="R33a7672eca294a59"/>
+          <a:blip xmlns:r="http://schemas.openxmlformats.org/officeDocument/2006/relationships" xmlns:a="http://schemas.openxmlformats.org/drawingml/2006/main" r:embed="R3d719e238e714fa9"/>
           <a:srcRect xmlns:a="http://schemas.openxmlformats.org/drawingml/2006/main" l="-3900" t="0" r="-3900" b="0"/>
           <a:stretch xmlns:a="http://schemas.openxmlformats.org/drawingml/2006/main"/>
         </p:blipFill>
@@ -8297,7 +8586,7 @@
           <p:nvPr/>
         </p:nvPicPr>
         <p:blipFill>
-          <a:blip xmlns:r="http://schemas.openxmlformats.org/officeDocument/2006/relationships" xmlns:a="http://schemas.openxmlformats.org/drawingml/2006/main" r:embed="Rd573b6d9bb824569"/>
+          <a:blip xmlns:r="http://schemas.openxmlformats.org/officeDocument/2006/relationships" xmlns:a="http://schemas.openxmlformats.org/drawingml/2006/main" r:embed="R49a3ef6ee2e34c2e"/>
           <a:srcRect xmlns:a="http://schemas.openxmlformats.org/drawingml/2006/main" l="-2083" t="0" r="-2083" b="0"/>
           <a:stretch xmlns:a="http://schemas.openxmlformats.org/drawingml/2006/main"/>
         </p:blipFill>
@@ -8462,7 +8751,7 @@
           <p:nvPr/>
         </p:nvPicPr>
         <p:blipFill>
-          <a:blip xmlns:r="http://schemas.openxmlformats.org/officeDocument/2006/relationships" xmlns:a="http://schemas.openxmlformats.org/drawingml/2006/main" r:embed="Rb388b62ace124596"/>
+          <a:blip xmlns:r="http://schemas.openxmlformats.org/officeDocument/2006/relationships" xmlns:a="http://schemas.openxmlformats.org/drawingml/2006/main" r:embed="R4a29ef20958d410a"/>
           <a:srcRect xmlns:a="http://schemas.openxmlformats.org/drawingml/2006/main" l="-12267" t="0" r="-12267" b="0"/>
           <a:stretch xmlns:a="http://schemas.openxmlformats.org/drawingml/2006/main"/>
         </p:blipFill>
@@ -8485,7 +8774,7 @@
           <p:nvPr/>
         </p:nvPicPr>
         <p:blipFill>
-          <a:blip xmlns:r="http://schemas.openxmlformats.org/officeDocument/2006/relationships" xmlns:a="http://schemas.openxmlformats.org/drawingml/2006/main" r:embed="R706a7815db6942ac"/>
+          <a:blip xmlns:r="http://schemas.openxmlformats.org/officeDocument/2006/relationships" xmlns:a="http://schemas.openxmlformats.org/drawingml/2006/main" r:embed="Ra1e81ddaad05458a"/>
           <a:srcRect xmlns:a="http://schemas.openxmlformats.org/drawingml/2006/main" l="-1491" t="0" r="-1491" b="0"/>
           <a:stretch xmlns:a="http://schemas.openxmlformats.org/drawingml/2006/main"/>
         </p:blipFill>
@@ -9747,7 +10036,7 @@
           <p:nvPr/>
         </p:nvPicPr>
         <p:blipFill>
-          <a:blip xmlns:r="http://schemas.openxmlformats.org/officeDocument/2006/relationships" xmlns:a="http://schemas.openxmlformats.org/drawingml/2006/main" r:embed="R78c70b5430c24dd2"/>
+          <a:blip xmlns:r="http://schemas.openxmlformats.org/officeDocument/2006/relationships" xmlns:a="http://schemas.openxmlformats.org/drawingml/2006/main" r:embed="Reca7134df5f1456f"/>
           <a:srcRect xmlns:a="http://schemas.openxmlformats.org/drawingml/2006/main" l="-2083" t="0" r="-2083" b="0"/>
           <a:stretch xmlns:a="http://schemas.openxmlformats.org/drawingml/2006/main"/>
         </p:blipFill>
@@ -9947,7 +10236,7 @@
           <p:nvPr/>
         </p:nvPicPr>
         <p:blipFill>
-          <a:blip xmlns:r="http://schemas.openxmlformats.org/officeDocument/2006/relationships" xmlns:a="http://schemas.openxmlformats.org/drawingml/2006/main" r:embed="R90ae5fe2e3c64622"/>
+          <a:blip xmlns:r="http://schemas.openxmlformats.org/officeDocument/2006/relationships" xmlns:a="http://schemas.openxmlformats.org/drawingml/2006/main" r:embed="R20b8e008c4a44b7f"/>
           <a:srcRect xmlns:a="http://schemas.openxmlformats.org/drawingml/2006/main" l="-14024" t="0" r="-14024" b="0"/>
           <a:stretch xmlns:a="http://schemas.openxmlformats.org/drawingml/2006/main"/>
         </p:blipFill>
@@ -11724,7 +12013,7 @@
           <p:nvPr/>
         </p:nvPicPr>
         <p:blipFill>
-          <a:blip xmlns:r="http://schemas.openxmlformats.org/officeDocument/2006/relationships" xmlns:a="http://schemas.openxmlformats.org/drawingml/2006/main" r:embed="Rce01db3b34434262"/>
+          <a:blip xmlns:r="http://schemas.openxmlformats.org/officeDocument/2006/relationships" xmlns:a="http://schemas.openxmlformats.org/drawingml/2006/main" r:embed="R5882b1072469473a"/>
           <a:srcRect xmlns:a="http://schemas.openxmlformats.org/drawingml/2006/main" l="-2083" t="0" r="-2083" b="0"/>
           <a:stretch xmlns:a="http://schemas.openxmlformats.org/drawingml/2006/main"/>
         </p:blipFill>
@@ -13133,7 +13422,7 @@
           <p:nvPr/>
         </p:nvPicPr>
         <p:blipFill>
-          <a:blip xmlns:r="http://schemas.openxmlformats.org/officeDocument/2006/relationships" xmlns:a="http://schemas.openxmlformats.org/drawingml/2006/main" r:embed="Rc8f057350a1546e8"/>
+          <a:blip xmlns:r="http://schemas.openxmlformats.org/officeDocument/2006/relationships" xmlns:a="http://schemas.openxmlformats.org/drawingml/2006/main" r:embed="Red44b79b8e3d4246"/>
           <a:srcRect xmlns:a="http://schemas.openxmlformats.org/drawingml/2006/main" l="-2083" t="0" r="-2083" b="0"/>
           <a:stretch xmlns:a="http://schemas.openxmlformats.org/drawingml/2006/main"/>
         </p:blipFill>
@@ -13298,7 +13587,7 @@
           <p:nvPr/>
         </p:nvPicPr>
         <p:blipFill>
-          <a:blip xmlns:r="http://schemas.openxmlformats.org/officeDocument/2006/relationships" xmlns:a="http://schemas.openxmlformats.org/drawingml/2006/main" r:embed="R42db0e848dc6400b"/>
+          <a:blip xmlns:r="http://schemas.openxmlformats.org/officeDocument/2006/relationships" xmlns:a="http://schemas.openxmlformats.org/drawingml/2006/main" r:embed="R526e0a1953ae4cdb"/>
           <a:srcRect xmlns:a="http://schemas.openxmlformats.org/drawingml/2006/main" l="0" t="-400" r="0" b="-400"/>
           <a:stretch xmlns:a="http://schemas.openxmlformats.org/drawingml/2006/main"/>
         </p:blipFill>
@@ -14933,7 +15222,7 @@
           <p:nvPr/>
         </p:nvPicPr>
         <p:blipFill>
-          <a:blip xmlns:r="http://schemas.openxmlformats.org/officeDocument/2006/relationships" xmlns:a="http://schemas.openxmlformats.org/drawingml/2006/main" r:embed="Ra9ee28aa1b574a2f"/>
+          <a:blip xmlns:r="http://schemas.openxmlformats.org/officeDocument/2006/relationships" xmlns:a="http://schemas.openxmlformats.org/drawingml/2006/main" r:embed="R43a7d537bd104c3f"/>
           <a:srcRect xmlns:a="http://schemas.openxmlformats.org/drawingml/2006/main" l="-2083" t="0" r="-2083" b="0"/>
           <a:stretch xmlns:a="http://schemas.openxmlformats.org/drawingml/2006/main"/>
         </p:blipFill>
@@ -15098,7 +15387,7 @@
           <p:nvPr/>
         </p:nvPicPr>
         <p:blipFill>
-          <a:blip xmlns:r="http://schemas.openxmlformats.org/officeDocument/2006/relationships" xmlns:a="http://schemas.openxmlformats.org/drawingml/2006/main" r:embed="Rafe72664e9de4243"/>
+          <a:blip xmlns:r="http://schemas.openxmlformats.org/officeDocument/2006/relationships" xmlns:a="http://schemas.openxmlformats.org/drawingml/2006/main" r:embed="R9f22110c01f74cd5"/>
           <a:srcRect xmlns:a="http://schemas.openxmlformats.org/drawingml/2006/main" l="0" t="-195" r="0" b="-195"/>
           <a:stretch xmlns:a="http://schemas.openxmlformats.org/drawingml/2006/main"/>
         </p:blipFill>
@@ -15892,7 +16181,7 @@
           <p:nvPr/>
         </p:nvPicPr>
         <p:blipFill>
-          <a:blip xmlns:r="http://schemas.openxmlformats.org/officeDocument/2006/relationships" xmlns:a="http://schemas.openxmlformats.org/drawingml/2006/main" r:embed="Rb4418f38ad754fd2"/>
+          <a:blip xmlns:r="http://schemas.openxmlformats.org/officeDocument/2006/relationships" xmlns:a="http://schemas.openxmlformats.org/drawingml/2006/main" r:embed="Ree7bbd78bf6b4265"/>
           <a:srcRect xmlns:a="http://schemas.openxmlformats.org/drawingml/2006/main" l="0" t="0" r="0" b="0"/>
           <a:stretch xmlns:a="http://schemas.openxmlformats.org/drawingml/2006/main"/>
         </p:blipFill>
@@ -15915,7 +16204,7 @@
           <p:nvPr/>
         </p:nvPicPr>
         <p:blipFill>
-          <a:blip xmlns:r="http://schemas.openxmlformats.org/officeDocument/2006/relationships" xmlns:a="http://schemas.openxmlformats.org/drawingml/2006/main" r:embed="R397794d5af374a39"/>
+          <a:blip xmlns:r="http://schemas.openxmlformats.org/officeDocument/2006/relationships" xmlns:a="http://schemas.openxmlformats.org/drawingml/2006/main" r:embed="R1b738889cc9f4c78"/>
           <a:srcRect xmlns:a="http://schemas.openxmlformats.org/drawingml/2006/main" l="0" t="-207" r="0" b="-207"/>
           <a:stretch xmlns:a="http://schemas.openxmlformats.org/drawingml/2006/main"/>
         </p:blipFill>
@@ -15938,7 +16227,7 @@
           <p:nvPr/>
         </p:nvPicPr>
         <p:blipFill>
-          <a:blip xmlns:r="http://schemas.openxmlformats.org/officeDocument/2006/relationships" xmlns:a="http://schemas.openxmlformats.org/drawingml/2006/main" r:embed="R115e4aa387ca49f3"/>
+          <a:blip xmlns:r="http://schemas.openxmlformats.org/officeDocument/2006/relationships" xmlns:a="http://schemas.openxmlformats.org/drawingml/2006/main" r:embed="R4b5a02082e924999"/>
           <a:srcRect xmlns:a="http://schemas.openxmlformats.org/drawingml/2006/main" l="-207" t="0" r="-207" b="0"/>
           <a:stretch xmlns:a="http://schemas.openxmlformats.org/drawingml/2006/main"/>
         </p:blipFill>
@@ -16722,7 +17011,7 @@
           <p:nvPr/>
         </p:nvPicPr>
         <p:blipFill>
-          <a:blip xmlns:r="http://schemas.openxmlformats.org/officeDocument/2006/relationships" xmlns:a="http://schemas.openxmlformats.org/drawingml/2006/main" r:embed="R69b121bd13324a37"/>
+          <a:blip xmlns:r="http://schemas.openxmlformats.org/officeDocument/2006/relationships" xmlns:a="http://schemas.openxmlformats.org/drawingml/2006/main" r:embed="R898d58baa7114bb4"/>
           <a:srcRect xmlns:a="http://schemas.openxmlformats.org/drawingml/2006/main" l="-2083" t="0" r="-2083" b="0"/>
           <a:stretch xmlns:a="http://schemas.openxmlformats.org/drawingml/2006/main"/>
         </p:blipFill>
@@ -17918,7 +18207,7 @@
           <p:nvPr/>
         </p:nvPicPr>
         <p:blipFill>
-          <a:blip xmlns:r="http://schemas.openxmlformats.org/officeDocument/2006/relationships" xmlns:a="http://schemas.openxmlformats.org/drawingml/2006/main" r:embed="R753e0de3a9724d11"/>
+          <a:blip xmlns:r="http://schemas.openxmlformats.org/officeDocument/2006/relationships" xmlns:a="http://schemas.openxmlformats.org/drawingml/2006/main" r:embed="Rb9c80349637f4499"/>
           <a:srcRect xmlns:a="http://schemas.openxmlformats.org/drawingml/2006/main" l="-2083" t="0" r="-2083" b="0"/>
           <a:stretch xmlns:a="http://schemas.openxmlformats.org/drawingml/2006/main"/>
         </p:blipFill>
@@ -17941,7 +18230,7 @@
           <p:nvPr/>
         </p:nvPicPr>
         <p:blipFill>
-          <a:blip xmlns:r="http://schemas.openxmlformats.org/officeDocument/2006/relationships" xmlns:a="http://schemas.openxmlformats.org/drawingml/2006/main" r:embed="R753e0de3a9724d11"/>
+          <a:blip xmlns:r="http://schemas.openxmlformats.org/officeDocument/2006/relationships" xmlns:a="http://schemas.openxmlformats.org/drawingml/2006/main" r:embed="Rb9c80349637f4499"/>
           <a:srcRect xmlns:a="http://schemas.openxmlformats.org/drawingml/2006/main" l="-2083" t="0" r="-2083" b="0"/>
           <a:stretch xmlns:a="http://schemas.openxmlformats.org/drawingml/2006/main"/>
         </p:blipFill>
@@ -20208,7 +20497,7 @@
           <p:nvPr/>
         </p:nvPicPr>
         <p:blipFill>
-          <a:blip xmlns:r="http://schemas.openxmlformats.org/officeDocument/2006/relationships" xmlns:a="http://schemas.openxmlformats.org/drawingml/2006/main" r:embed="Rc98625a9428444fc"/>
+          <a:blip xmlns:r="http://schemas.openxmlformats.org/officeDocument/2006/relationships" xmlns:a="http://schemas.openxmlformats.org/drawingml/2006/main" r:embed="R508f42fa0ff44368"/>
           <a:srcRect xmlns:a="http://schemas.openxmlformats.org/drawingml/2006/main" l="-2083" t="0" r="-2083" b="0"/>
           <a:stretch xmlns:a="http://schemas.openxmlformats.org/drawingml/2006/main"/>
         </p:blipFill>
@@ -21635,7 +21924,7 @@
           <p:nvPr/>
         </p:nvPicPr>
         <p:blipFill>
-          <a:blip xmlns:r="http://schemas.openxmlformats.org/officeDocument/2006/relationships" xmlns:a="http://schemas.openxmlformats.org/drawingml/2006/main" r:embed="R5748e5f50fa448b6"/>
+          <a:blip xmlns:r="http://schemas.openxmlformats.org/officeDocument/2006/relationships" xmlns:a="http://schemas.openxmlformats.org/drawingml/2006/main" r:embed="Ra19f7aff8eb04721"/>
           <a:srcRect xmlns:a="http://schemas.openxmlformats.org/drawingml/2006/main" l="-2083" t="0" r="-2083" b="0"/>
           <a:stretch xmlns:a="http://schemas.openxmlformats.org/drawingml/2006/main"/>
         </p:blipFill>
@@ -21767,7 +22056,7 @@
           <p:nvPr/>
         </p:nvPicPr>
         <p:blipFill>
-          <a:blip xmlns:r="http://schemas.openxmlformats.org/officeDocument/2006/relationships" xmlns:a="http://schemas.openxmlformats.org/drawingml/2006/main" r:embed="Reef09faca45a4135"/>
+          <a:blip xmlns:r="http://schemas.openxmlformats.org/officeDocument/2006/relationships" xmlns:a="http://schemas.openxmlformats.org/drawingml/2006/main" r:embed="R383ee5ba89a94465"/>
           <a:srcRect xmlns:a="http://schemas.openxmlformats.org/drawingml/2006/main" l="-2083" t="0" r="-2083" b="0"/>
           <a:stretch xmlns:a="http://schemas.openxmlformats.org/drawingml/2006/main"/>
         </p:blipFill>
@@ -21790,7 +22079,7 @@
           <p:nvPr/>
         </p:nvPicPr>
         <p:blipFill>
-          <a:blip xmlns:r="http://schemas.openxmlformats.org/officeDocument/2006/relationships" xmlns:a="http://schemas.openxmlformats.org/drawingml/2006/main" r:embed="Reef09faca45a4135"/>
+          <a:blip xmlns:r="http://schemas.openxmlformats.org/officeDocument/2006/relationships" xmlns:a="http://schemas.openxmlformats.org/drawingml/2006/main" r:embed="R383ee5ba89a94465"/>
           <a:srcRect xmlns:a="http://schemas.openxmlformats.org/drawingml/2006/main" l="-2083" t="0" r="-2083" b="0"/>
           <a:stretch xmlns:a="http://schemas.openxmlformats.org/drawingml/2006/main"/>
         </p:blipFill>
@@ -22984,7 +23273,7 @@
           <p:nvPr/>
         </p:nvPicPr>
         <p:blipFill>
-          <a:blip xmlns:r="http://schemas.openxmlformats.org/officeDocument/2006/relationships" xmlns:a="http://schemas.openxmlformats.org/drawingml/2006/main" r:embed="R7dd4603c730d4a08"/>
+          <a:blip xmlns:r="http://schemas.openxmlformats.org/officeDocument/2006/relationships" xmlns:a="http://schemas.openxmlformats.org/drawingml/2006/main" r:embed="Rf9715b0462794239"/>
           <a:srcRect xmlns:a="http://schemas.openxmlformats.org/drawingml/2006/main" l="-2083" t="0" r="-2083" b="0"/>
           <a:stretch xmlns:a="http://schemas.openxmlformats.org/drawingml/2006/main"/>
         </p:blipFill>
@@ -23079,7 +23368,7 @@
           <p:nvPr/>
         </p:nvPicPr>
         <p:blipFill>
-          <a:blip xmlns:r="http://schemas.openxmlformats.org/officeDocument/2006/relationships" xmlns:a="http://schemas.openxmlformats.org/drawingml/2006/main" r:embed="Rf0cc86a3f8b044bb"/>
+          <a:blip xmlns:r="http://schemas.openxmlformats.org/officeDocument/2006/relationships" xmlns:a="http://schemas.openxmlformats.org/drawingml/2006/main" r:embed="R178aa24844e04073"/>
           <a:srcRect xmlns:a="http://schemas.openxmlformats.org/drawingml/2006/main" l="-400" t="0" r="-400" b="0"/>
           <a:stretch xmlns:a="http://schemas.openxmlformats.org/drawingml/2006/main"/>
         </p:blipFill>
@@ -23102,7 +23391,7 @@
           <p:nvPr/>
         </p:nvPicPr>
         <p:blipFill>
-          <a:blip xmlns:r="http://schemas.openxmlformats.org/officeDocument/2006/relationships" xmlns:a="http://schemas.openxmlformats.org/drawingml/2006/main" r:embed="Re5890b9c987d40f4"/>
+          <a:blip xmlns:r="http://schemas.openxmlformats.org/officeDocument/2006/relationships" xmlns:a="http://schemas.openxmlformats.org/drawingml/2006/main" r:embed="R1bdd9e0f190840bb"/>
           <a:srcRect xmlns:a="http://schemas.openxmlformats.org/drawingml/2006/main" l="0" t="-2078" r="0" b="-2078"/>
           <a:stretch xmlns:a="http://schemas.openxmlformats.org/drawingml/2006/main"/>
         </p:blipFill>
@@ -23125,7 +23414,7 @@
           <p:nvPr/>
         </p:nvPicPr>
         <p:blipFill>
-          <a:blip xmlns:r="http://schemas.openxmlformats.org/officeDocument/2006/relationships" xmlns:a="http://schemas.openxmlformats.org/drawingml/2006/main" r:embed="R73792d1839b14c5d"/>
+          <a:blip xmlns:r="http://schemas.openxmlformats.org/officeDocument/2006/relationships" xmlns:a="http://schemas.openxmlformats.org/drawingml/2006/main" r:embed="Rcedcf97475454531"/>
           <a:srcRect xmlns:a="http://schemas.openxmlformats.org/drawingml/2006/main" l="-2083" t="0" r="-2083" b="0"/>
           <a:stretch xmlns:a="http://schemas.openxmlformats.org/drawingml/2006/main"/>
         </p:blipFill>
@@ -25241,7 +25530,7 @@
           <p:nvPr/>
         </p:nvPicPr>
         <p:blipFill>
-          <a:blip xmlns:r="http://schemas.openxmlformats.org/officeDocument/2006/relationships" xmlns:a="http://schemas.openxmlformats.org/drawingml/2006/main" r:embed="R5bd87305d1154d15"/>
+          <a:blip xmlns:r="http://schemas.openxmlformats.org/officeDocument/2006/relationships" xmlns:a="http://schemas.openxmlformats.org/drawingml/2006/main" r:embed="R6e4369d687b24fc4"/>
           <a:srcRect xmlns:a="http://schemas.openxmlformats.org/drawingml/2006/main" l="-2083" t="0" r="-2083" b="0"/>
           <a:stretch xmlns:a="http://schemas.openxmlformats.org/drawingml/2006/main"/>
         </p:blipFill>
@@ -25371,7 +25660,7 @@
           <p:nvPr/>
         </p:nvPicPr>
         <p:blipFill>
-          <a:blip xmlns:r="http://schemas.openxmlformats.org/officeDocument/2006/relationships" xmlns:a="http://schemas.openxmlformats.org/drawingml/2006/main" r:embed="R8a45165b69a14728"/>
+          <a:blip xmlns:r="http://schemas.openxmlformats.org/officeDocument/2006/relationships" xmlns:a="http://schemas.openxmlformats.org/drawingml/2006/main" r:embed="Rc9329952f01d45a8"/>
           <a:srcRect xmlns:a="http://schemas.openxmlformats.org/drawingml/2006/main" l="-9959" t="0" r="-9959" b="0"/>
           <a:stretch xmlns:a="http://schemas.openxmlformats.org/drawingml/2006/main"/>
         </p:blipFill>
@@ -25394,7 +25683,7 @@
           <p:nvPr/>
         </p:nvPicPr>
         <p:blipFill>
-          <a:blip xmlns:r="http://schemas.openxmlformats.org/officeDocument/2006/relationships" xmlns:a="http://schemas.openxmlformats.org/drawingml/2006/main" r:embed="Raa6ead0d91af40be"/>
+          <a:blip xmlns:r="http://schemas.openxmlformats.org/officeDocument/2006/relationships" xmlns:a="http://schemas.openxmlformats.org/drawingml/2006/main" r:embed="Rbc9abd10d79040ed"/>
           <a:srcRect xmlns:a="http://schemas.openxmlformats.org/drawingml/2006/main" l="-9959" t="0" r="-9959" b="0"/>
           <a:stretch xmlns:a="http://schemas.openxmlformats.org/drawingml/2006/main"/>
         </p:blipFill>
@@ -25417,7 +25706,7 @@
           <p:nvPr/>
         </p:nvPicPr>
         <p:blipFill>
-          <a:blip xmlns:r="http://schemas.openxmlformats.org/officeDocument/2006/relationships" xmlns:a="http://schemas.openxmlformats.org/drawingml/2006/main" r:embed="Ra4afd8c8dc1f4552"/>
+          <a:blip xmlns:r="http://schemas.openxmlformats.org/officeDocument/2006/relationships" xmlns:a="http://schemas.openxmlformats.org/drawingml/2006/main" r:embed="Ra4da59eba04f4a4b"/>
           <a:srcRect xmlns:a="http://schemas.openxmlformats.org/drawingml/2006/main" l="0" t="-2089" r="0" b="-2089"/>
           <a:stretch xmlns:a="http://schemas.openxmlformats.org/drawingml/2006/main"/>
         </p:blipFill>
@@ -25440,7 +25729,7 @@
           <p:nvPr/>
         </p:nvPicPr>
         <p:blipFill>
-          <a:blip xmlns:r="http://schemas.openxmlformats.org/officeDocument/2006/relationships" xmlns:a="http://schemas.openxmlformats.org/drawingml/2006/main" r:embed="Ra4afd8c8dc1f4552"/>
+          <a:blip xmlns:r="http://schemas.openxmlformats.org/officeDocument/2006/relationships" xmlns:a="http://schemas.openxmlformats.org/drawingml/2006/main" r:embed="Ra4da59eba04f4a4b"/>
           <a:srcRect xmlns:a="http://schemas.openxmlformats.org/drawingml/2006/main" l="0" t="-2089" r="0" b="-2089"/>
           <a:stretch xmlns:a="http://schemas.openxmlformats.org/drawingml/2006/main"/>
         </p:blipFill>
@@ -26317,7 +26606,7 @@
           <p:nvPr/>
         </p:nvPicPr>
         <p:blipFill>
-          <a:blip xmlns:r="http://schemas.openxmlformats.org/officeDocument/2006/relationships" xmlns:a="http://schemas.openxmlformats.org/drawingml/2006/main" r:embed="R35503f081c324108"/>
+          <a:blip xmlns:r="http://schemas.openxmlformats.org/officeDocument/2006/relationships" xmlns:a="http://schemas.openxmlformats.org/drawingml/2006/main" r:embed="R48762ad6bf684f87"/>
           <a:srcRect xmlns:a="http://schemas.openxmlformats.org/drawingml/2006/main" l="-2083" t="0" r="-2083" b="0"/>
           <a:stretch xmlns:a="http://schemas.openxmlformats.org/drawingml/2006/main"/>
         </p:blipFill>
@@ -26519,7 +26808,7 @@
           <p:nvPr/>
         </p:nvPicPr>
         <p:blipFill>
-          <a:blip xmlns:r="http://schemas.openxmlformats.org/officeDocument/2006/relationships" xmlns:a="http://schemas.openxmlformats.org/drawingml/2006/main" r:embed="R503e064cffc34005"/>
+          <a:blip xmlns:r="http://schemas.openxmlformats.org/officeDocument/2006/relationships" xmlns:a="http://schemas.openxmlformats.org/drawingml/2006/main" r:embed="R455f08bce1504210"/>
           <a:srcRect xmlns:a="http://schemas.openxmlformats.org/drawingml/2006/main" l="-2985" t="0" r="-2985" b="0"/>
           <a:stretch xmlns:a="http://schemas.openxmlformats.org/drawingml/2006/main"/>
         </p:blipFill>
@@ -26542,7 +26831,7 @@
           <p:nvPr/>
         </p:nvPicPr>
         <p:blipFill>
-          <a:blip xmlns:r="http://schemas.openxmlformats.org/officeDocument/2006/relationships" xmlns:a="http://schemas.openxmlformats.org/drawingml/2006/main" r:embed="R14e09030be9c4de9"/>
+          <a:blip xmlns:r="http://schemas.openxmlformats.org/officeDocument/2006/relationships" xmlns:a="http://schemas.openxmlformats.org/drawingml/2006/main" r:embed="Rbe381ee16c1141b0"/>
           <a:srcRect xmlns:a="http://schemas.openxmlformats.org/drawingml/2006/main" l="-21842" t="0" r="-21842" b="0"/>
           <a:stretch xmlns:a="http://schemas.openxmlformats.org/drawingml/2006/main"/>
         </p:blipFill>
@@ -27156,7 +27445,7 @@
           <p:nvPr/>
         </p:nvPicPr>
         <p:blipFill>
-          <a:blip xmlns:r="http://schemas.openxmlformats.org/officeDocument/2006/relationships" xmlns:a="http://schemas.openxmlformats.org/drawingml/2006/main" r:embed="R316906bd5e744f1a"/>
+          <a:blip xmlns:r="http://schemas.openxmlformats.org/officeDocument/2006/relationships" xmlns:a="http://schemas.openxmlformats.org/drawingml/2006/main" r:embed="R77c19011bc4e4f35"/>
           <a:srcRect xmlns:a="http://schemas.openxmlformats.org/drawingml/2006/main" l="-2083" t="0" r="-2083" b="0"/>
           <a:stretch xmlns:a="http://schemas.openxmlformats.org/drawingml/2006/main"/>
         </p:blipFill>
@@ -27393,7 +27682,7 @@
           <p:nvPr/>
         </p:nvPicPr>
         <p:blipFill>
-          <a:blip xmlns:r="http://schemas.openxmlformats.org/officeDocument/2006/relationships" xmlns:a="http://schemas.openxmlformats.org/drawingml/2006/main" r:embed="R278d6df8674f4965"/>
+          <a:blip xmlns:r="http://schemas.openxmlformats.org/officeDocument/2006/relationships" xmlns:a="http://schemas.openxmlformats.org/drawingml/2006/main" r:embed="R28386150e29c47b4"/>
           <a:srcRect xmlns:a="http://schemas.openxmlformats.org/drawingml/2006/main" l="-6952" t="0" r="-6952" b="0"/>
           <a:stretch xmlns:a="http://schemas.openxmlformats.org/drawingml/2006/main"/>
         </p:blipFill>
@@ -27416,7 +27705,7 @@
           <p:nvPr/>
         </p:nvPicPr>
         <p:blipFill>
-          <a:blip xmlns:r="http://schemas.openxmlformats.org/officeDocument/2006/relationships" xmlns:a="http://schemas.openxmlformats.org/drawingml/2006/main" r:embed="R9936b98263c74bab"/>
+          <a:blip xmlns:r="http://schemas.openxmlformats.org/officeDocument/2006/relationships" xmlns:a="http://schemas.openxmlformats.org/drawingml/2006/main" r:embed="Raed1a95eb7184b39"/>
           <a:srcRect xmlns:a="http://schemas.openxmlformats.org/drawingml/2006/main" l="-6952" t="0" r="-6952" b="0"/>
           <a:stretch xmlns:a="http://schemas.openxmlformats.org/drawingml/2006/main"/>
         </p:blipFill>
@@ -28096,7 +28385,7 @@
           <p:nvPr/>
         </p:nvPicPr>
         <p:blipFill>
-          <a:blip xmlns:r="http://schemas.openxmlformats.org/officeDocument/2006/relationships" xmlns:a="http://schemas.openxmlformats.org/drawingml/2006/main" r:embed="R124412eeeb7e4538"/>
+          <a:blip xmlns:r="http://schemas.openxmlformats.org/officeDocument/2006/relationships" xmlns:a="http://schemas.openxmlformats.org/drawingml/2006/main" r:embed="R8db4b8fe365c4d39"/>
           <a:srcRect xmlns:a="http://schemas.openxmlformats.org/drawingml/2006/main" l="-2083" t="0" r="-2083" b="0"/>
           <a:stretch xmlns:a="http://schemas.openxmlformats.org/drawingml/2006/main"/>
         </p:blipFill>
@@ -30558,7 +30847,7 @@
           <p:nvPr/>
         </p:nvPicPr>
         <p:blipFill>
-          <a:blip xmlns:r="http://schemas.openxmlformats.org/officeDocument/2006/relationships" xmlns:a="http://schemas.openxmlformats.org/drawingml/2006/main" r:embed="Rae749f825954449a"/>
+          <a:blip xmlns:r="http://schemas.openxmlformats.org/officeDocument/2006/relationships" xmlns:a="http://schemas.openxmlformats.org/drawingml/2006/main" r:embed="R2b14045962ad4740"/>
           <a:srcRect xmlns:a="http://schemas.openxmlformats.org/drawingml/2006/main" l="-2083" t="0" r="-2083" b="0"/>
           <a:stretch xmlns:a="http://schemas.openxmlformats.org/drawingml/2006/main"/>
         </p:blipFill>
@@ -30651,7 +30940,7 @@
           <p:nvPr/>
         </p:nvPicPr>
         <p:blipFill>
-          <a:blip xmlns:r="http://schemas.openxmlformats.org/officeDocument/2006/relationships" xmlns:a="http://schemas.openxmlformats.org/drawingml/2006/main" r:embed="R26ab0b33ac114521"/>
+          <a:blip xmlns:r="http://schemas.openxmlformats.org/officeDocument/2006/relationships" xmlns:a="http://schemas.openxmlformats.org/drawingml/2006/main" r:embed="R411cc3b156d44fe9"/>
           <a:srcRect xmlns:a="http://schemas.openxmlformats.org/drawingml/2006/main" l="0" t="-17083" r="0" b="-17083"/>
           <a:stretch xmlns:a="http://schemas.openxmlformats.org/drawingml/2006/main"/>
         </p:blipFill>

</xml_diff>